<commit_message>
Update slide and exercise
</commit_message>
<xml_diff>
--- a/Slide/C/1.Variable.pptx
+++ b/Slide/C/1.Variable.pptx
@@ -265,7 +265,7 @@
           <a:p>
             <a:fld id="{ECA3AE87-C17F-4F2C-92FF-7FE21F8A66BE}" type="datetimeFigureOut">
               <a:rPr lang="en-US" smtClean="0"/>
-              <a:t>3/18/2025</a:t>
+              <a:t>3/25/2025</a:t>
             </a:fld>
             <a:endParaRPr lang="en-US"/>
           </a:p>
@@ -433,7 +433,7 @@
           <a:p>
             <a:fld id="{ECA3AE87-C17F-4F2C-92FF-7FE21F8A66BE}" type="datetimeFigureOut">
               <a:rPr lang="en-US" smtClean="0"/>
-              <a:t>3/18/2025</a:t>
+              <a:t>3/25/2025</a:t>
             </a:fld>
             <a:endParaRPr lang="en-US"/>
           </a:p>
@@ -611,7 +611,7 @@
           <a:p>
             <a:fld id="{ECA3AE87-C17F-4F2C-92FF-7FE21F8A66BE}" type="datetimeFigureOut">
               <a:rPr lang="en-US" smtClean="0"/>
-              <a:t>3/18/2025</a:t>
+              <a:t>3/25/2025</a:t>
             </a:fld>
             <a:endParaRPr lang="en-US"/>
           </a:p>
@@ -779,7 +779,7 @@
           <a:p>
             <a:fld id="{ECA3AE87-C17F-4F2C-92FF-7FE21F8A66BE}" type="datetimeFigureOut">
               <a:rPr lang="en-US" smtClean="0"/>
-              <a:t>3/18/2025</a:t>
+              <a:t>3/25/2025</a:t>
             </a:fld>
             <a:endParaRPr lang="en-US"/>
           </a:p>
@@ -1024,7 +1024,7 @@
           <a:p>
             <a:fld id="{ECA3AE87-C17F-4F2C-92FF-7FE21F8A66BE}" type="datetimeFigureOut">
               <a:rPr lang="en-US" smtClean="0"/>
-              <a:t>3/18/2025</a:t>
+              <a:t>3/25/2025</a:t>
             </a:fld>
             <a:endParaRPr lang="en-US"/>
           </a:p>
@@ -1253,7 +1253,7 @@
           <a:p>
             <a:fld id="{ECA3AE87-C17F-4F2C-92FF-7FE21F8A66BE}" type="datetimeFigureOut">
               <a:rPr lang="en-US" smtClean="0"/>
-              <a:t>3/18/2025</a:t>
+              <a:t>3/25/2025</a:t>
             </a:fld>
             <a:endParaRPr lang="en-US"/>
           </a:p>
@@ -1617,7 +1617,7 @@
           <a:p>
             <a:fld id="{ECA3AE87-C17F-4F2C-92FF-7FE21F8A66BE}" type="datetimeFigureOut">
               <a:rPr lang="en-US" smtClean="0"/>
-              <a:t>3/18/2025</a:t>
+              <a:t>3/25/2025</a:t>
             </a:fld>
             <a:endParaRPr lang="en-US"/>
           </a:p>
@@ -1734,7 +1734,7 @@
           <a:p>
             <a:fld id="{ECA3AE87-C17F-4F2C-92FF-7FE21F8A66BE}" type="datetimeFigureOut">
               <a:rPr lang="en-US" smtClean="0"/>
-              <a:t>3/18/2025</a:t>
+              <a:t>3/25/2025</a:t>
             </a:fld>
             <a:endParaRPr lang="en-US"/>
           </a:p>
@@ -1829,7 +1829,7 @@
           <a:p>
             <a:fld id="{ECA3AE87-C17F-4F2C-92FF-7FE21F8A66BE}" type="datetimeFigureOut">
               <a:rPr lang="en-US" smtClean="0"/>
-              <a:t>3/18/2025</a:t>
+              <a:t>3/25/2025</a:t>
             </a:fld>
             <a:endParaRPr lang="en-US"/>
           </a:p>
@@ -2104,7 +2104,7 @@
           <a:p>
             <a:fld id="{ECA3AE87-C17F-4F2C-92FF-7FE21F8A66BE}" type="datetimeFigureOut">
               <a:rPr lang="en-US" smtClean="0"/>
-              <a:t>3/18/2025</a:t>
+              <a:t>3/25/2025</a:t>
             </a:fld>
             <a:endParaRPr lang="en-US"/>
           </a:p>
@@ -2356,7 +2356,7 @@
           <a:p>
             <a:fld id="{ECA3AE87-C17F-4F2C-92FF-7FE21F8A66BE}" type="datetimeFigureOut">
               <a:rPr lang="en-US" smtClean="0"/>
-              <a:t>3/18/2025</a:t>
+              <a:t>3/25/2025</a:t>
             </a:fld>
             <a:endParaRPr lang="en-US"/>
           </a:p>
@@ -2567,7 +2567,7 @@
           <a:p>
             <a:fld id="{ECA3AE87-C17F-4F2C-92FF-7FE21F8A66BE}" type="datetimeFigureOut">
               <a:rPr lang="en-US" smtClean="0"/>
-              <a:t>3/18/2025</a:t>
+              <a:t>3/25/2025</a:t>
             </a:fld>
             <a:endParaRPr lang="en-US"/>
           </a:p>
@@ -4349,7 +4349,7 @@
         <p:spPr>
           <a:xfrm>
             <a:off x="1350432" y="4514239"/>
-            <a:ext cx="3496734" cy="71642"/>
+            <a:ext cx="7651328" cy="0"/>
           </a:xfrm>
           <a:prstGeom prst="line">
             <a:avLst/>
@@ -4387,7 +4387,7 @@
         <p:spPr>
           <a:xfrm>
             <a:off x="1206499" y="5405769"/>
-            <a:ext cx="3496734" cy="67733"/>
+            <a:ext cx="7876541" cy="0"/>
           </a:xfrm>
           <a:prstGeom prst="line">
             <a:avLst/>
@@ -4652,7 +4652,7 @@
         </p:nvSpPr>
         <p:spPr>
           <a:xfrm>
-            <a:off x="1820336" y="4767225"/>
+            <a:off x="1807847" y="4633027"/>
             <a:ext cx="499532" cy="457200"/>
           </a:xfrm>
           <a:prstGeom prst="rect">
@@ -4681,6 +4681,204 @@
             <a:r>
               <a:rPr lang="en-US" dirty="0"/>
               <a:t>%</a:t>
+            </a:r>
+          </a:p>
+        </p:txBody>
+      </p:sp>
+      <p:sp>
+        <p:nvSpPr>
+          <p:cNvPr id="5" name="Rectangle 4">
+            <a:extLst>
+              <a:ext uri="{FF2B5EF4-FFF2-40B4-BE49-F238E27FC236}">
+                <a16:creationId xmlns:a16="http://schemas.microsoft.com/office/drawing/2014/main" id="{AF0EB3A0-0A30-00A5-C416-2CCBA00B3C6B}"/>
+              </a:ext>
+            </a:extLst>
+          </p:cNvPr>
+          <p:cNvSpPr/>
+          <p:nvPr/>
+        </p:nvSpPr>
+        <p:spPr>
+          <a:xfrm>
+            <a:off x="4936489" y="4843425"/>
+            <a:ext cx="479213" cy="381000"/>
+          </a:xfrm>
+          <a:prstGeom prst="rect">
+            <a:avLst/>
+          </a:prstGeom>
+        </p:spPr>
+        <p:style>
+          <a:lnRef idx="1">
+            <a:schemeClr val="accent6"/>
+          </a:lnRef>
+          <a:fillRef idx="3">
+            <a:schemeClr val="accent6"/>
+          </a:fillRef>
+          <a:effectRef idx="2">
+            <a:schemeClr val="accent6"/>
+          </a:effectRef>
+          <a:fontRef idx="minor">
+            <a:schemeClr val="lt1"/>
+          </a:fontRef>
+        </p:style>
+        <p:txBody>
+          <a:bodyPr rtlCol="0" anchor="ctr"/>
+          <a:lstStyle/>
+          <a:p>
+            <a:pPr algn="ctr"/>
+            <a:r>
+              <a:rPr lang="en-US" dirty="0"/>
+              <a:t>e</a:t>
+            </a:r>
+          </a:p>
+        </p:txBody>
+      </p:sp>
+      <p:sp>
+        <p:nvSpPr>
+          <p:cNvPr id="7" name="Rectangle 6">
+            <a:extLst>
+              <a:ext uri="{FF2B5EF4-FFF2-40B4-BE49-F238E27FC236}">
+                <a16:creationId xmlns:a16="http://schemas.microsoft.com/office/drawing/2014/main" id="{2EA11D45-66EB-9019-E157-2C7C2BFABDFD}"/>
+              </a:ext>
+            </a:extLst>
+          </p:cNvPr>
+          <p:cNvSpPr/>
+          <p:nvPr/>
+        </p:nvSpPr>
+        <p:spPr>
+          <a:xfrm>
+            <a:off x="2070102" y="3892973"/>
+            <a:ext cx="1195068" cy="434600"/>
+          </a:xfrm>
+          <a:prstGeom prst="rect">
+            <a:avLst/>
+          </a:prstGeom>
+        </p:spPr>
+        <p:style>
+          <a:lnRef idx="2">
+            <a:schemeClr val="accent1">
+              <a:shade val="15000"/>
+            </a:schemeClr>
+          </a:lnRef>
+          <a:fillRef idx="1">
+            <a:schemeClr val="accent1"/>
+          </a:fillRef>
+          <a:effectRef idx="0">
+            <a:schemeClr val="accent1"/>
+          </a:effectRef>
+          <a:fontRef idx="minor">
+            <a:schemeClr val="lt1"/>
+          </a:fontRef>
+        </p:style>
+        <p:txBody>
+          <a:bodyPr rtlCol="0" anchor="ctr"/>
+          <a:lstStyle/>
+          <a:p>
+            <a:pPr algn="ctr"/>
+            <a:r>
+              <a:rPr lang="en-US" dirty="0" err="1"/>
+              <a:t>Getchar</a:t>
+            </a:r>
+            <a:r>
+              <a:rPr lang="en-US" dirty="0"/>
+              <a:t>()</a:t>
+            </a:r>
+          </a:p>
+        </p:txBody>
+      </p:sp>
+      <p:sp>
+        <p:nvSpPr>
+          <p:cNvPr id="12" name="Rectangle 11">
+            <a:extLst>
+              <a:ext uri="{FF2B5EF4-FFF2-40B4-BE49-F238E27FC236}">
+                <a16:creationId xmlns:a16="http://schemas.microsoft.com/office/drawing/2014/main" id="{4B8F4DE2-68C3-1A54-11D7-0D84DCAD891A}"/>
+              </a:ext>
+            </a:extLst>
+          </p:cNvPr>
+          <p:cNvSpPr/>
+          <p:nvPr/>
+        </p:nvSpPr>
+        <p:spPr>
+          <a:xfrm>
+            <a:off x="2070102" y="5728577"/>
+            <a:ext cx="1195068" cy="434600"/>
+          </a:xfrm>
+          <a:prstGeom prst="rect">
+            <a:avLst/>
+          </a:prstGeom>
+        </p:spPr>
+        <p:style>
+          <a:lnRef idx="3">
+            <a:schemeClr val="lt1"/>
+          </a:lnRef>
+          <a:fillRef idx="1">
+            <a:schemeClr val="accent4"/>
+          </a:fillRef>
+          <a:effectRef idx="1">
+            <a:schemeClr val="accent4"/>
+          </a:effectRef>
+          <a:fontRef idx="minor">
+            <a:schemeClr val="lt1"/>
+          </a:fontRef>
+        </p:style>
+        <p:txBody>
+          <a:bodyPr rtlCol="0" anchor="ctr"/>
+          <a:lstStyle/>
+          <a:p>
+            <a:pPr algn="ctr"/>
+            <a:r>
+              <a:rPr lang="en-US" dirty="0" err="1"/>
+              <a:t>Putchar</a:t>
+            </a:r>
+            <a:r>
+              <a:rPr lang="en-US" dirty="0"/>
+              <a:t>()</a:t>
+            </a:r>
+          </a:p>
+        </p:txBody>
+      </p:sp>
+      <p:sp>
+        <p:nvSpPr>
+          <p:cNvPr id="14" name="Rectangle 13">
+            <a:extLst>
+              <a:ext uri="{FF2B5EF4-FFF2-40B4-BE49-F238E27FC236}">
+                <a16:creationId xmlns:a16="http://schemas.microsoft.com/office/drawing/2014/main" id="{32D54ABF-F667-E88E-DFA6-0DFC02AC6D71}"/>
+              </a:ext>
+            </a:extLst>
+          </p:cNvPr>
+          <p:cNvSpPr/>
+          <p:nvPr/>
+        </p:nvSpPr>
+        <p:spPr>
+          <a:xfrm>
+            <a:off x="8188960" y="4683760"/>
+            <a:ext cx="812800" cy="540664"/>
+          </a:xfrm>
+          <a:prstGeom prst="rect">
+            <a:avLst/>
+          </a:prstGeom>
+        </p:spPr>
+        <p:style>
+          <a:lnRef idx="1">
+            <a:schemeClr val="dk1"/>
+          </a:lnRef>
+          <a:fillRef idx="3">
+            <a:schemeClr val="dk1"/>
+          </a:fillRef>
+          <a:effectRef idx="2">
+            <a:schemeClr val="dk1"/>
+          </a:effectRef>
+          <a:fontRef idx="minor">
+            <a:schemeClr val="lt1"/>
+          </a:fontRef>
+        </p:style>
+        <p:txBody>
+          <a:bodyPr rtlCol="0" anchor="ctr"/>
+          <a:lstStyle/>
+          <a:p>
+            <a:pPr algn="ctr"/>
+            <a:r>
+              <a:rPr lang="en-US" dirty="0"/>
+              <a:t>EOF</a:t>
             </a:r>
           </a:p>
         </p:txBody>

</xml_diff>